<commit_message>
Build MuleTrace: graph detector, investigator app, Snowflake & Cloudflare deploy
- backend: synthetic bank generator with KYC data and legitimate look-alikes,
  pure-stdlib graph detector (structuring, fan-out/fan-in, layering,
  round-trip) with explainable risk scores, end-to-end pipeline
- frontend: Svelte investigator workspace (alert queue, network graph,
  evidence + policy, copilot with citations, STR draft, audit log, PII
  masking by role) and Cloudflare Pages Functions calling Snowflake Cortex
- snowflake: numbered SQL for setup, load, dynamic tables, Snowpark
  detector + task, Cortex Search, semantic view, Cortex Agent, governance,
  cases and AI_COMPLETE STR drafting; custom CoCo skill
- deck: slide 10/11 now show real demo output and measured accuracy

Co-Authored-By: Claude Opus 5.5 <noreply@anthropic.com>
</commit_message>
<xml_diff>
--- a/deck/MuleTrace_MVP_Brief.pptx
+++ b/deck/MuleTrace_MVP_Brief.pptx
@@ -119,12 +119,12 @@
   <p:extLst>
     <p:ext uri="{521415D9-36F7-43E2-AB2F-B90AF26B5E84}">
       <p14:sectionLst xmlns:p14="http://schemas.microsoft.com/office/powerpoint/2010/main">
-        <p14:section name="Introduction" id="{274d0d86-812c-ec37-2d35-0aadaa6e6a75}">
+        <p14:section name="Introduction" id="{1549ab2f-d775-b750-072b-5e7b9e29fa4b}">
           <p14:sldIdLst>
             <p14:sldId id="256"/>
           </p14:sldIdLst>
         </p14:section>
-        <p14:section name="Problem Brief" id="{4e06125a-b218-e17a-e4d0-2341f1d56a1e}">
+        <p14:section name="Problem Brief" id="{889e51a2-80a6-fa17-9859-4ec93e96e625}">
           <p14:sldIdLst>
             <p14:sldId id="257"/>
             <p14:sldId id="258"/>
@@ -132,7 +132,7 @@
             <p14:sldId id="260"/>
           </p14:sldIdLst>
         </p14:section>
-        <p14:section name="Solution &amp; Architecture" id="{dfe0abf5-38bb-2d08-13ff-819c8241999e}">
+        <p14:section name="Solution &amp; Architecture" id="{2729eea5-4720-658d-a7f6-5e5258278c71}">
           <p14:sldIdLst>
             <p14:sldId id="261"/>
             <p14:sldId id="262"/>
@@ -141,13 +141,13 @@
             <p14:sldId id="265"/>
           </p14:sldIdLst>
         </p14:section>
-        <p14:section name="Impact" id="{b30595cf-252d-0f92-5cfd-ca1b251d9b0d}">
+        <p14:section name="Impact" id="{5374e9ad-b74f-af7f-2a0b-404be696adef}">
           <p14:sldIdLst>
             <p14:sldId id="266"/>
             <p14:sldId id="267"/>
           </p14:sldIdLst>
         </p14:section>
-        <p14:section name="Close" id="{65d993a5-61c2-938e-171c-2dfc6279f669}">
+        <p14:section name="Close" id="{97c4e980-8bb3-0082-ca7e-d6578342a974}">
           <p14:sldIdLst>
             <p14:sldId id="268"/>
           </p14:sldIdLst>
@@ -3418,7 +3418,7 @@
                   <a:schemeClr val="tx1"/>
                 </a:solidFill>
               </a:rPr>
-              <a:t>Which accounts received over ₹5 lakh in sub-₹1,000 transfers last week? Does that breach our policy?</a:t>
+              <a:t>Which accounts received over ₹5 lakh in sub-₹1,000 transfers? Does that breach our policy?</a:t>
             </a:r>
             <a:endParaRPr lang="en-US" sz="1300" dirty="0"/>
           </a:p>
@@ -3572,7 +3572,7 @@
                   <a:schemeClr val="tx1"/>
                 </a:solidFill>
               </a:rPr>
-              <a:t>AC48213907 received ₹9.96 lakh in 2,000 transfers from 100 accounts (11–15 Sep).</a:t>
+              <a:t>AC79448796 received ₹9.94 lakh in 2,000 transfers from 100 accounts (11–15 Sep).</a:t>
             </a:r>
             <a:endParaRPr lang="en-US" sz="1300" dirty="0"/>
           </a:p>
@@ -3586,7 +3586,7 @@
                   <a:schemeClr val="tx1"/>
                 </a:solidFill>
               </a:rPr>
-              <a:t>Pattern: structuring · Risk 92/100. </a:t>
+              <a:t>Finding F001: structuring · Risk 98/100. </a:t>
             </a:r>
             <a:pPr indent="0" marL="0">
               <a:buNone/>
@@ -3597,7 +3597,7 @@
                   <a:schemeClr val="tx1"/>
                 </a:solidFill>
               </a:rPr>
-              <a:t>This breaches policy AML-04 §3.2 (repeated sub-threshold credits from unrelated senders).</a:t>
+              <a:t>Matches policy AML-04 §3.2: 10+ unrelated senders, 5+ transfers of ≤₹2,000 each, same amount, &gt;₹1 lakh total.</a:t>
             </a:r>
             <a:endParaRPr lang="en-US" sz="1300" dirty="0"/>
           </a:p>
@@ -3749,7 +3749,7 @@
                   <a:schemeClr val="accent6"/>
                 </a:solidFill>
               </a:rPr>
-              <a:t>Illustrative output on synthetic data</a:t>
+              <a:t>Actual output from the MuleTrace demo on synthetic data</a:t>
             </a:r>
             <a:endParaRPr lang="en-US" sz="1000" dirty="0"/>
           </a:p>
@@ -4962,7 +4962,7 @@
                 <a:ea typeface="Arial" pitchFamily="34" charset="-122"/>
                 <a:cs typeface="Arial" pitchFamily="34" charset="-120"/>
               </a:rPr>
-              <a:t>Precision / recall</a:t>
+              <a:t>100% / 99.95%</a:t>
             </a:r>
             <a:endParaRPr lang="en-US" sz="2800" dirty="0"/>
           </a:p>
@@ -4998,7 +4998,7 @@
                   <a:schemeClr val="tx1"/>
                 </a:solidFill>
               </a:rPr>
-              <a:t>Scored live against ground-truth labels planted in the synthetic data</a:t>
+              <a:t>Precision / recall against ground-truth labels planted in the synthetic data</a:t>
             </a:r>
             <a:endParaRPr lang="en-US" sz="1400" dirty="0"/>
           </a:p>

</xml_diff>

<commit_message>
Go live on Cloudflare Pages; add live demo links to deck and README
- deployed to https://muletrace.pages.dev (Pages + Functions)
- `npm run deploy` in frontend/ for one-command redeploys
- deck title/closing and README carry the live URL and deep links

Co-Authored-By: Claude Opus 5.5 <noreply@anthropic.com>
</commit_message>
<xml_diff>
--- a/deck/MuleTrace_MVP_Brief.pptx
+++ b/deck/MuleTrace_MVP_Brief.pptx
@@ -124,12 +124,12 @@
   <p:extLst>
     <p:ext uri="{521415D9-36F7-43E2-AB2F-B90AF26B5E84}">
       <p14:sectionLst xmlns:p14="http://schemas.microsoft.com/office/powerpoint/2010/main">
-        <p14:section name="Introduction" id="{54c6e12c-4e9c-d4ed-2f5a-e7b6f8957444}">
+        <p14:section name="Introduction" id="{ce6d801a-216b-40a7-cdf9-cb51a80fc761}">
           <p14:sldIdLst>
             <p14:sldId id="256"/>
           </p14:sldIdLst>
         </p14:section>
-        <p14:section name="Problem Brief" id="{0c21c770-e2c1-df2c-eda7-8fbfb0c73ba0}">
+        <p14:section name="Problem Brief" id="{32c41831-c1c0-be67-82b7-35b4630fad3e}">
           <p14:sldIdLst>
             <p14:sldId id="257"/>
             <p14:sldId id="258"/>
@@ -137,7 +137,7 @@
             <p14:sldId id="260"/>
           </p14:sldIdLst>
         </p14:section>
-        <p14:section name="Solution &amp; Architecture" id="{6cf1b639-a860-48d7-4bd8-455787662638}">
+        <p14:section name="Solution &amp; Architecture" id="{b2d51d10-b478-3d15-1dc2-31ab25b120fe}">
           <p14:sldIdLst>
             <p14:sldId id="261"/>
             <p14:sldId id="262"/>
@@ -149,7 +149,7 @@
             <p14:sldId id="268"/>
           </p14:sldIdLst>
         </p14:section>
-        <p14:section name="Impact" id="{304c90c7-a12e-2ac0-044a-587f15f7f937}">
+        <p14:section name="Impact" id="{25dd5aa5-55a9-3c86-e2fd-b7f16122f42c}">
           <p14:sldIdLst>
             <p14:sldId id="269"/>
             <p14:sldId id="270"/>
@@ -157,7 +157,7 @@
             <p14:sldId id="272"/>
           </p14:sldIdLst>
         </p14:section>
-        <p14:section name="Close" id="{c17fc6bc-d4aa-1ec8-2c2e-29f1bd415070}">
+        <p14:section name="Close" id="{3556d0d1-3c44-07af-52ab-cea959b42286}">
           <p14:sldIdLst>
             <p14:sldId id="273"/>
           </p14:sldIdLst>
@@ -3072,7 +3072,7 @@
                   <a:schemeClr val="bg2"/>
                 </a:solidFill>
               </a:rPr>
-              <a:t>github.com/SwasthikaDev/SnowflakeCoCoCLI</a:t>
+              <a:t>Live demo: muletrace.pages.dev  ·  github.com/SwasthikaDev/SnowflakeCoCoCLI</a:t>
             </a:r>
             <a:endParaRPr lang="en-US" sz="1000" dirty="0"/>
           </a:p>
@@ -12435,6 +12435,31 @@
                   <a:schemeClr val="accent5"/>
                 </a:solidFill>
               </a:rPr>
+              <a:t>Live demo  </a:t>
+            </a:r>
+            <a:pPr indent="0" marL="0">
+              <a:buNone/>
+            </a:pPr>
+            <a:r>
+              <a:rPr lang="en-US" sz="1200" dirty="0">
+                <a:solidFill>
+                  <a:schemeClr val="bg1"/>
+                </a:solidFill>
+              </a:rPr>
+              <a:t>muletrace.pages.dev</a:t>
+            </a:r>
+            <a:endParaRPr lang="en-US" sz="1200" dirty="0"/>
+          </a:p>
+          <a:p>
+            <a:pPr indent="0" marL="0">
+              <a:buNone/>
+            </a:pPr>
+            <a:r>
+              <a:rPr lang="en-US" sz="1200" b="1" dirty="0">
+                <a:solidFill>
+                  <a:schemeClr val="accent5"/>
+                </a:solidFill>
+              </a:rPr>
               <a:t>Code  </a:t>
             </a:r>
             <a:pPr indent="0" marL="0">
@@ -17124,7 +17149,7 @@
                   <a:schemeClr val="accent6"/>
                 </a:solidFill>
               </a:rPr>
-              <a:t>Working app on synthetic data</a:t>
+              <a:t>Working app on synthetic data · muletrace.pages.dev</a:t>
             </a:r>
             <a:endParaRPr lang="en-US" sz="1000" dirty="0"/>
           </a:p>

</xml_diff>

<commit_message>
Run MuleTrace on Snowflake; deck shows live Snowflake + real CoCo CLI session
Co-Authored-By: Claude Opus 5.5 <noreply@anthropic.com>
</commit_message>
<xml_diff>
--- a/deck/MuleTrace_MVP_Brief.pptx
+++ b/deck/MuleTrace_MVP_Brief.pptx
@@ -128,13 +128,13 @@
   <p:extLst>
     <p:ext uri="{521415D9-36F7-43E2-AB2F-B90AF26B5E84}">
       <p14:sectionLst xmlns:p14="http://schemas.microsoft.com/office/powerpoint/2010/main">
-        <p14:section name="Introduction" id="{7a907a22-f5c5-3398-b6b3-b0c5b6eb2871}">
+        <p14:section name="Introduction" id="{946c37a6-d90b-8e62-de74-e07628a5cb50}">
           <p14:sldIdLst>
             <p14:sldId id="256"/>
             <p14:sldId id="257"/>
           </p14:sldIdLst>
         </p14:section>
-        <p14:section name="Problem Brief" id="{d83cc0a5-cbc0-0141-a15f-43b408bb38d6}">
+        <p14:section name="Problem Brief" id="{b9f2f994-71ba-29bd-35b1-30aa2362e73c}">
           <p14:sldIdLst>
             <p14:sldId id="258"/>
             <p14:sldId id="259"/>
@@ -143,7 +143,7 @@
             <p14:sldId id="262"/>
           </p14:sldIdLst>
         </p14:section>
-        <p14:section name="Solution &amp; Architecture" id="{229f3a29-e184-de8f-feec-6eebab840338}">
+        <p14:section name="Solution &amp; Architecture" id="{afd5ec48-c6b2-cfc1-d5bf-8946aa7ac77d}">
           <p14:sldIdLst>
             <p14:sldId id="263"/>
             <p14:sldId id="264"/>
@@ -156,7 +156,7 @@
             <p14:sldId id="271"/>
           </p14:sldIdLst>
         </p14:section>
-        <p14:section name="Impact" id="{751f77ad-c331-5a77-d519-dcb1e3f59d7c}">
+        <p14:section name="Impact" id="{c532ebcb-bc60-7337-6903-6ed084f232c2}">
           <p14:sldIdLst>
             <p14:sldId id="272"/>
             <p14:sldId id="273"/>
@@ -165,7 +165,7 @@
             <p14:sldId id="276"/>
           </p14:sldIdLst>
         </p14:section>
-        <p14:section name="Close" id="{52062e60-252a-3c79-3b07-e3af458c6fc4}">
+        <p14:section name="Close" id="{e3f3e853-b9c9-0b98-5a1a-68d1313aa8c6}">
           <p14:sldIdLst>
             <p14:sldId id="277"/>
           </p14:sldIdLst>
@@ -7289,7 +7289,7 @@
                   <a:schemeClr val="tx1"/>
                 </a:solidFill>
               </a:rPr>
-              <a:t>masking &amp; row-access policies on PII · lineage · ACCESS_HISTORY audit trail</a:t>
+              <a:t>role-aware secure views mask PII · ground truth hidden · least-privilege roles</a:t>
             </a:r>
             <a:endParaRPr lang="en-US" sz="1100" dirty="0"/>
           </a:p>
@@ -7479,696 +7479,41 @@
       </p:sp>
       <p:sp>
         <p:nvSpPr>
-          <p:cNvPr id="4" name="Text 2"/>
-          <p:cNvSpPr txBox="1"/>
-          <p:nvPr/>
-        </p:nvSpPr>
-        <p:spPr>
-          <a:xfrm>
-            <a:off x="457200" y="1234440"/>
-            <a:ext cx="2606040" cy="228600"/>
-          </a:xfrm>
-          <a:prstGeom prst="rect">
-            <a:avLst/>
-          </a:prstGeom>
-          <a:noFill/>
-          <a:ln/>
-        </p:spPr>
-        <p:txBody>
-          <a:bodyPr wrap="square" lIns="0" tIns="0" rIns="0" bIns="0" rtlCol="0" anchor="t"/>
-          <a:lstStyle/>
-          <a:p>
-            <a:pPr indent="0" marL="0">
-              <a:buNone/>
-            </a:pPr>
-            <a:r>
-              <a:rPr lang="en-US" sz="1100" b="1" spc="100" kern="0" dirty="0">
-                <a:solidFill>
-                  <a:schemeClr val="accent5"/>
-                </a:solidFill>
-              </a:rPr>
-              <a:t>INPUT</a:t>
-            </a:r>
-            <a:endParaRPr lang="en-US" sz="1100" dirty="0"/>
-          </a:p>
-        </p:txBody>
-      </p:sp>
-      <p:sp>
-        <p:nvSpPr>
-          <p:cNvPr id="5" name="Shape 3"/>
-          <p:cNvSpPr/>
-          <p:nvPr/>
-        </p:nvSpPr>
-        <p:spPr>
-          <a:xfrm>
-            <a:off x="457200" y="1536192"/>
-            <a:ext cx="2606040" cy="2331720"/>
+          <p:cNvPr id="4" name="Shape 2"/>
+          <p:cNvSpPr/>
+          <p:nvPr/>
+        </p:nvSpPr>
+        <p:spPr>
+          <a:xfrm>
+            <a:off x="2935224" y="1197864"/>
+            <a:ext cx="5788152" cy="3291840"/>
           </a:xfrm>
           <a:prstGeom prst="roundRect">
             <a:avLst>
-              <a:gd name="adj" fmla="val 3137"/>
+              <a:gd name="adj" fmla="val 1667"/>
             </a:avLst>
           </a:prstGeom>
           <a:solidFill>
-            <a:schemeClr val="tx2"/>
+            <a:schemeClr val="bg1"/>
           </a:solidFill>
-          <a:ln/>
-        </p:spPr>
-      </p:sp>
-      <p:sp>
-        <p:nvSpPr>
-          <p:cNvPr id="6" name="Shape 4"/>
-          <p:cNvSpPr/>
-          <p:nvPr/>
-        </p:nvSpPr>
-        <p:spPr>
-          <a:xfrm>
-            <a:off x="621792" y="1664208"/>
-            <a:ext cx="91440" cy="91440"/>
-          </a:xfrm>
-          <a:prstGeom prst="ellipse">
-            <a:avLst/>
-          </a:prstGeom>
-          <a:solidFill>
-            <a:srgbClr val="E4572E"/>
-          </a:solidFill>
-          <a:ln/>
-        </p:spPr>
-      </p:sp>
-      <p:sp>
-        <p:nvSpPr>
-          <p:cNvPr id="7" name="Shape 5"/>
-          <p:cNvSpPr/>
-          <p:nvPr/>
-        </p:nvSpPr>
-        <p:spPr>
-          <a:xfrm>
-            <a:off x="786384" y="1664208"/>
-            <a:ext cx="91440" cy="91440"/>
-          </a:xfrm>
-          <a:prstGeom prst="ellipse">
-            <a:avLst/>
-          </a:prstGeom>
-          <a:solidFill>
-            <a:srgbClr val="E8A33D"/>
-          </a:solidFill>
-          <a:ln/>
-        </p:spPr>
-      </p:sp>
-      <p:sp>
-        <p:nvSpPr>
-          <p:cNvPr id="8" name="Shape 6"/>
-          <p:cNvSpPr/>
-          <p:nvPr/>
-        </p:nvSpPr>
-        <p:spPr>
-          <a:xfrm>
-            <a:off x="950976" y="1664208"/>
-            <a:ext cx="91440" cy="91440"/>
-          </a:xfrm>
-          <a:prstGeom prst="ellipse">
-            <a:avLst/>
-          </a:prstGeom>
-          <a:solidFill>
-            <a:srgbClr val="1B998B"/>
-          </a:solidFill>
-          <a:ln/>
-        </p:spPr>
-      </p:sp>
-      <p:sp>
-        <p:nvSpPr>
-          <p:cNvPr id="9" name="Text 7"/>
-          <p:cNvSpPr txBox="1"/>
-          <p:nvPr/>
-        </p:nvSpPr>
-        <p:spPr>
-          <a:xfrm>
-            <a:off x="621792" y="1920240"/>
-            <a:ext cx="2286000" cy="457200"/>
-          </a:xfrm>
-          <a:prstGeom prst="rect">
-            <a:avLst/>
-          </a:prstGeom>
-          <a:noFill/>
-          <a:ln/>
-        </p:spPr>
-        <p:txBody>
-          <a:bodyPr wrap="square" lIns="0" tIns="0" rIns="0" bIns="0" rtlCol="0" anchor="t"/>
-          <a:lstStyle/>
-          <a:p>
-            <a:pPr indent="0" marL="0">
-              <a:buNone/>
-            </a:pPr>
-            <a:r>
-              <a:rPr lang="en-US" sz="1200" b="1" dirty="0">
-                <a:solidFill>
-                  <a:schemeClr val="accent5"/>
-                </a:solidFill>
-                <a:latin typeface="Courier New" pitchFamily="34" charset="0"/>
-                <a:ea typeface="Courier New" pitchFamily="34" charset="-122"/>
-                <a:cs typeface="Courier New" pitchFamily="34" charset="-120"/>
-              </a:rPr>
-              <a:t>&gt; </a:t>
-            </a:r>
-            <a:pPr indent="0" marL="0">
-              <a:buNone/>
-            </a:pPr>
-            <a:r>
-              <a:rPr lang="en-US" sz="1200" b="1" dirty="0">
-                <a:solidFill>
-                  <a:schemeClr val="bg1"/>
-                </a:solidFill>
-                <a:latin typeface="Courier New" pitchFamily="34" charset="0"/>
-                <a:ea typeface="Courier New" pitchFamily="34" charset="-122"/>
-                <a:cs typeface="Courier New" pitchFamily="34" charset="-120"/>
-              </a:rPr>
-              <a:t>$muletrace-ingest</a:t>
-            </a:r>
-            <a:endParaRPr lang="en-US" sz="1200" dirty="0"/>
-          </a:p>
-        </p:txBody>
-      </p:sp>
-      <p:sp>
-        <p:nvSpPr>
-          <p:cNvPr id="10" name="Text 8"/>
-          <p:cNvSpPr txBox="1"/>
-          <p:nvPr/>
-        </p:nvSpPr>
-        <p:spPr>
-          <a:xfrm>
-            <a:off x="621792" y="2468880"/>
-            <a:ext cx="2286000" cy="1280160"/>
-          </a:xfrm>
-          <a:prstGeom prst="rect">
-            <a:avLst/>
-          </a:prstGeom>
-          <a:noFill/>
-          <a:ln/>
-        </p:spPr>
-        <p:txBody>
-          <a:bodyPr wrap="square" lIns="0" tIns="0" rIns="0" bIns="0" rtlCol="0" anchor="t"/>
-          <a:lstStyle/>
-          <a:p>
-            <a:pPr indent="0" marL="0">
-              <a:buNone/>
-            </a:pPr>
-            <a:r>
-              <a:rPr lang="en-US" sz="1200" dirty="0">
-                <a:solidFill>
-                  <a:schemeClr val="bg2"/>
-                </a:solidFill>
-              </a:rPr>
-              <a:t>Loads 10,259 transactions, 603 accounts and 17 policy sections into Snowflake and verifies the counts.</a:t>
-            </a:r>
-            <a:endParaRPr lang="en-US" sz="1200" dirty="0"/>
-          </a:p>
-        </p:txBody>
-      </p:sp>
-      <p:sp>
-        <p:nvSpPr>
-          <p:cNvPr id="11" name="Shape 9"/>
-          <p:cNvSpPr/>
-          <p:nvPr/>
-        </p:nvSpPr>
-        <p:spPr>
-          <a:xfrm>
-            <a:off x="3090672" y="2697480"/>
-            <a:ext cx="155448" cy="914"/>
-          </a:xfrm>
-          <a:prstGeom prst="line">
-            <a:avLst/>
-          </a:prstGeom>
-          <a:noFill/>
-          <a:ln w="19050">
+          <a:ln w="9525">
             <a:solidFill>
-              <a:schemeClr val="accent6"/>
+              <a:srgbClr val="D5DCE5"/>
             </a:solidFill>
             <a:prstDash val="solid"/>
-            <a:tailEnd type="triangle"/>
           </a:ln>
-        </p:spPr>
-      </p:sp>
-      <p:sp>
-        <p:nvSpPr>
-          <p:cNvPr id="12" name="Text 10"/>
-          <p:cNvSpPr txBox="1"/>
-          <p:nvPr/>
-        </p:nvSpPr>
-        <p:spPr>
-          <a:xfrm>
-            <a:off x="3268980" y="1234440"/>
-            <a:ext cx="2606040" cy="228600"/>
-          </a:xfrm>
-          <a:prstGeom prst="rect">
-            <a:avLst/>
-          </a:prstGeom>
-          <a:noFill/>
-          <a:ln/>
-        </p:spPr>
-        <p:txBody>
-          <a:bodyPr wrap="square" lIns="0" tIns="0" rIns="0" bIns="0" rtlCol="0" anchor="t"/>
-          <a:lstStyle/>
-          <a:p>
-            <a:pPr indent="0" marL="0">
-              <a:buNone/>
-            </a:pPr>
-            <a:r>
-              <a:rPr lang="en-US" sz="1100" b="1" spc="100" kern="0" dirty="0">
-                <a:solidFill>
-                  <a:schemeClr val="accent3"/>
-                </a:solidFill>
-              </a:rPr>
-              <a:t>PROCESSING</a:t>
-            </a:r>
-            <a:endParaRPr lang="en-US" sz="1100" dirty="0"/>
-          </a:p>
-        </p:txBody>
-      </p:sp>
-      <p:sp>
-        <p:nvSpPr>
-          <p:cNvPr id="13" name="Shape 11"/>
-          <p:cNvSpPr/>
-          <p:nvPr/>
-        </p:nvSpPr>
-        <p:spPr>
-          <a:xfrm>
-            <a:off x="3268980" y="1536192"/>
-            <a:ext cx="2606040" cy="2331720"/>
-          </a:xfrm>
-          <a:prstGeom prst="roundRect">
-            <a:avLst>
-              <a:gd name="adj" fmla="val 3137"/>
-            </a:avLst>
-          </a:prstGeom>
-          <a:solidFill>
-            <a:schemeClr val="tx2"/>
-          </a:solidFill>
-          <a:ln/>
-        </p:spPr>
-      </p:sp>
-      <p:sp>
-        <p:nvSpPr>
-          <p:cNvPr id="14" name="Shape 12"/>
-          <p:cNvSpPr/>
-          <p:nvPr/>
-        </p:nvSpPr>
-        <p:spPr>
-          <a:xfrm>
-            <a:off x="3433572" y="1664208"/>
-            <a:ext cx="91440" cy="91440"/>
-          </a:xfrm>
-          <a:prstGeom prst="ellipse">
-            <a:avLst/>
-          </a:prstGeom>
-          <a:solidFill>
-            <a:srgbClr val="E4572E"/>
-          </a:solidFill>
-          <a:ln/>
-        </p:spPr>
-      </p:sp>
-      <p:sp>
-        <p:nvSpPr>
-          <p:cNvPr id="15" name="Shape 13"/>
-          <p:cNvSpPr/>
-          <p:nvPr/>
-        </p:nvSpPr>
-        <p:spPr>
-          <a:xfrm>
-            <a:off x="3598164" y="1664208"/>
-            <a:ext cx="91440" cy="91440"/>
-          </a:xfrm>
-          <a:prstGeom prst="ellipse">
-            <a:avLst/>
-          </a:prstGeom>
-          <a:solidFill>
-            <a:srgbClr val="E8A33D"/>
-          </a:solidFill>
-          <a:ln/>
-        </p:spPr>
-      </p:sp>
-      <p:sp>
-        <p:nvSpPr>
-          <p:cNvPr id="16" name="Shape 14"/>
-          <p:cNvSpPr/>
-          <p:nvPr/>
-        </p:nvSpPr>
-        <p:spPr>
-          <a:xfrm>
-            <a:off x="3762756" y="1664208"/>
-            <a:ext cx="91440" cy="91440"/>
-          </a:xfrm>
-          <a:prstGeom prst="ellipse">
-            <a:avLst/>
-          </a:prstGeom>
-          <a:solidFill>
-            <a:srgbClr val="1B998B"/>
-          </a:solidFill>
-          <a:ln/>
-        </p:spPr>
-      </p:sp>
-      <p:sp>
-        <p:nvSpPr>
-          <p:cNvPr id="17" name="Text 15"/>
-          <p:cNvSpPr txBox="1"/>
-          <p:nvPr/>
-        </p:nvSpPr>
-        <p:spPr>
-          <a:xfrm>
-            <a:off x="3433572" y="1920240"/>
-            <a:ext cx="2286000" cy="457200"/>
-          </a:xfrm>
-          <a:prstGeom prst="rect">
-            <a:avLst/>
-          </a:prstGeom>
-          <a:noFill/>
-          <a:ln/>
-        </p:spPr>
-        <p:txBody>
-          <a:bodyPr wrap="square" lIns="0" tIns="0" rIns="0" bIns="0" rtlCol="0" anchor="t"/>
-          <a:lstStyle/>
-          <a:p>
-            <a:pPr indent="0" marL="0">
-              <a:buNone/>
-            </a:pPr>
-            <a:r>
-              <a:rPr lang="en-US" sz="1200" b="1" dirty="0">
-                <a:solidFill>
-                  <a:schemeClr val="accent3"/>
-                </a:solidFill>
-                <a:latin typeface="Courier New" pitchFamily="34" charset="0"/>
-                <a:ea typeface="Courier New" pitchFamily="34" charset="-122"/>
-                <a:cs typeface="Courier New" pitchFamily="34" charset="-120"/>
-              </a:rPr>
-              <a:t>&gt; </a:t>
-            </a:r>
-            <a:pPr indent="0" marL="0">
-              <a:buNone/>
-            </a:pPr>
-            <a:r>
-              <a:rPr lang="en-US" sz="1200" b="1" dirty="0">
-                <a:solidFill>
-                  <a:schemeClr val="bg1"/>
-                </a:solidFill>
-                <a:latin typeface="Courier New" pitchFamily="34" charset="0"/>
-                <a:ea typeface="Courier New" pitchFamily="34" charset="-122"/>
-                <a:cs typeface="Courier New" pitchFamily="34" charset="-120"/>
-              </a:rPr>
-              <a:t>$muletrace-detect</a:t>
-            </a:r>
-            <a:endParaRPr lang="en-US" sz="1200" dirty="0"/>
-          </a:p>
-        </p:txBody>
-      </p:sp>
-      <p:sp>
-        <p:nvSpPr>
-          <p:cNvPr id="18" name="Text 16"/>
-          <p:cNvSpPr txBox="1"/>
-          <p:nvPr/>
-        </p:nvSpPr>
-        <p:spPr>
-          <a:xfrm>
-            <a:off x="3433572" y="2468880"/>
-            <a:ext cx="2286000" cy="1280160"/>
-          </a:xfrm>
-          <a:prstGeom prst="rect">
-            <a:avLst/>
-          </a:prstGeom>
-          <a:noFill/>
-          <a:ln/>
-        </p:spPr>
-        <p:txBody>
-          <a:bodyPr wrap="square" lIns="0" tIns="0" rIns="0" bIns="0" rtlCol="0" anchor="t"/>
-          <a:lstStyle/>
-          <a:p>
-            <a:pPr indent="0" marL="0">
-              <a:buNone/>
-            </a:pPr>
-            <a:r>
-              <a:rPr lang="en-US" sz="1200" dirty="0">
-                <a:solidFill>
-                  <a:schemeClr val="bg2"/>
-                </a:solidFill>
-              </a:rPr>
-              <a:t>Refreshes Dynamic Tables, runs the Snowpark graph detector and ranks 6 laundering networks.</a:t>
-            </a:r>
-            <a:endParaRPr lang="en-US" sz="1200" dirty="0"/>
-          </a:p>
-        </p:txBody>
-      </p:sp>
-      <p:sp>
-        <p:nvSpPr>
-          <p:cNvPr id="19" name="Shape 17"/>
-          <p:cNvSpPr/>
-          <p:nvPr/>
-        </p:nvSpPr>
-        <p:spPr>
-          <a:xfrm>
-            <a:off x="5902452" y="2697480"/>
-            <a:ext cx="155448" cy="914"/>
-          </a:xfrm>
-          <a:prstGeom prst="line">
-            <a:avLst/>
-          </a:prstGeom>
-          <a:noFill/>
-          <a:ln w="19050">
-            <a:solidFill>
-              <a:schemeClr val="accent6"/>
-            </a:solidFill>
-            <a:prstDash val="solid"/>
-            <a:tailEnd type="triangle"/>
-          </a:ln>
-        </p:spPr>
-      </p:sp>
-      <p:sp>
-        <p:nvSpPr>
-          <p:cNvPr id="20" name="Text 18"/>
-          <p:cNvSpPr txBox="1"/>
-          <p:nvPr/>
-        </p:nvSpPr>
-        <p:spPr>
-          <a:xfrm>
-            <a:off x="6080760" y="1234440"/>
-            <a:ext cx="2606040" cy="228600"/>
-          </a:xfrm>
-          <a:prstGeom prst="rect">
-            <a:avLst/>
-          </a:prstGeom>
-          <a:noFill/>
-          <a:ln/>
-        </p:spPr>
-        <p:txBody>
-          <a:bodyPr wrap="square" lIns="0" tIns="0" rIns="0" bIns="0" rtlCol="0" anchor="t"/>
-          <a:lstStyle/>
-          <a:p>
-            <a:pPr indent="0" marL="0">
-              <a:buNone/>
-            </a:pPr>
-            <a:r>
-              <a:rPr lang="en-US" sz="1100" b="1" spc="100" kern="0" dirty="0">
-                <a:solidFill>
-                  <a:schemeClr val="accent2"/>
-                </a:solidFill>
-              </a:rPr>
-              <a:t>OUTPUT</a:t>
-            </a:r>
-            <a:endParaRPr lang="en-US" sz="1100" dirty="0"/>
-          </a:p>
-        </p:txBody>
-      </p:sp>
-      <p:sp>
-        <p:nvSpPr>
-          <p:cNvPr id="21" name="Shape 19"/>
-          <p:cNvSpPr/>
-          <p:nvPr/>
-        </p:nvSpPr>
-        <p:spPr>
-          <a:xfrm>
-            <a:off x="6080760" y="1536192"/>
-            <a:ext cx="2606040" cy="2331720"/>
-          </a:xfrm>
-          <a:prstGeom prst="roundRect">
-            <a:avLst>
-              <a:gd name="adj" fmla="val 3137"/>
-            </a:avLst>
-          </a:prstGeom>
-          <a:solidFill>
-            <a:schemeClr val="tx2"/>
-          </a:solidFill>
-          <a:ln/>
-        </p:spPr>
-      </p:sp>
-      <p:sp>
-        <p:nvSpPr>
-          <p:cNvPr id="22" name="Shape 20"/>
-          <p:cNvSpPr/>
-          <p:nvPr/>
-        </p:nvSpPr>
-        <p:spPr>
-          <a:xfrm>
-            <a:off x="6245352" y="1664208"/>
-            <a:ext cx="91440" cy="91440"/>
-          </a:xfrm>
-          <a:prstGeom prst="ellipse">
-            <a:avLst/>
-          </a:prstGeom>
-          <a:solidFill>
-            <a:srgbClr val="E4572E"/>
-          </a:solidFill>
-          <a:ln/>
-        </p:spPr>
-      </p:sp>
-      <p:sp>
-        <p:nvSpPr>
-          <p:cNvPr id="23" name="Shape 21"/>
-          <p:cNvSpPr/>
-          <p:nvPr/>
-        </p:nvSpPr>
-        <p:spPr>
-          <a:xfrm>
-            <a:off x="6409944" y="1664208"/>
-            <a:ext cx="91440" cy="91440"/>
-          </a:xfrm>
-          <a:prstGeom prst="ellipse">
-            <a:avLst/>
-          </a:prstGeom>
-          <a:solidFill>
-            <a:srgbClr val="E8A33D"/>
-          </a:solidFill>
-          <a:ln/>
-        </p:spPr>
-      </p:sp>
-      <p:sp>
-        <p:nvSpPr>
-          <p:cNvPr id="24" name="Shape 22"/>
-          <p:cNvSpPr/>
-          <p:nvPr/>
-        </p:nvSpPr>
-        <p:spPr>
-          <a:xfrm>
-            <a:off x="6574536" y="1664208"/>
-            <a:ext cx="91440" cy="91440"/>
-          </a:xfrm>
-          <a:prstGeom prst="ellipse">
-            <a:avLst/>
-          </a:prstGeom>
-          <a:solidFill>
-            <a:srgbClr val="1B998B"/>
-          </a:solidFill>
-          <a:ln/>
-        </p:spPr>
-      </p:sp>
-      <p:sp>
-        <p:nvSpPr>
-          <p:cNvPr id="25" name="Text 23"/>
-          <p:cNvSpPr txBox="1"/>
-          <p:nvPr/>
-        </p:nvSpPr>
-        <p:spPr>
-          <a:xfrm>
-            <a:off x="6245352" y="1920240"/>
-            <a:ext cx="2286000" cy="457200"/>
-          </a:xfrm>
-          <a:prstGeom prst="rect">
-            <a:avLst/>
-          </a:prstGeom>
-          <a:noFill/>
-          <a:ln/>
-        </p:spPr>
-        <p:txBody>
-          <a:bodyPr wrap="square" lIns="0" tIns="0" rIns="0" bIns="0" rtlCol="0" anchor="t"/>
-          <a:lstStyle/>
-          <a:p>
-            <a:pPr indent="0" marL="0">
-              <a:buNone/>
-            </a:pPr>
-            <a:r>
-              <a:rPr lang="en-US" sz="1200" b="1" dirty="0">
-                <a:solidFill>
-                  <a:schemeClr val="accent2"/>
-                </a:solidFill>
-                <a:latin typeface="Courier New" pitchFamily="34" charset="0"/>
-                <a:ea typeface="Courier New" pitchFamily="34" charset="-122"/>
-                <a:cs typeface="Courier New" pitchFamily="34" charset="-120"/>
-              </a:rPr>
-              <a:t>&gt; </a:t>
-            </a:r>
-            <a:pPr indent="0" marL="0">
-              <a:buNone/>
-            </a:pPr>
-            <a:r>
-              <a:rPr lang="en-US" sz="1200" b="1" dirty="0">
-                <a:solidFill>
-                  <a:schemeClr val="bg1"/>
-                </a:solidFill>
-                <a:latin typeface="Courier New" pitchFamily="34" charset="0"/>
-                <a:ea typeface="Courier New" pitchFamily="34" charset="-122"/>
-                <a:cs typeface="Courier New" pitchFamily="34" charset="-120"/>
-              </a:rPr>
-              <a:t>$muletrace-investigate F001</a:t>
-            </a:r>
-            <a:endParaRPr lang="en-US" sz="1200" dirty="0"/>
-          </a:p>
-        </p:txBody>
-      </p:sp>
-      <p:sp>
-        <p:nvSpPr>
-          <p:cNvPr id="26" name="Text 24"/>
-          <p:cNvSpPr txBox="1"/>
-          <p:nvPr/>
-        </p:nvSpPr>
-        <p:spPr>
-          <a:xfrm>
-            <a:off x="6245352" y="2468880"/>
-            <a:ext cx="2286000" cy="1280160"/>
-          </a:xfrm>
-          <a:prstGeom prst="rect">
-            <a:avLst/>
-          </a:prstGeom>
-          <a:noFill/>
-          <a:ln/>
-        </p:spPr>
-        <p:txBody>
-          <a:bodyPr wrap="square" lIns="0" tIns="0" rIns="0" bIns="0" rtlCol="0" anchor="t"/>
-          <a:lstStyle/>
-          <a:p>
-            <a:pPr indent="0" marL="0">
-              <a:buNone/>
-            </a:pPr>
-            <a:r>
-              <a:rPr lang="en-US" sz="1200" dirty="0">
-                <a:solidFill>
-                  <a:schemeClr val="bg2"/>
-                </a:solidFill>
-              </a:rPr>
-              <a:t>Pulls the evidence pack, quotes AML-04 §3.2, logs the decision and drafts the STR with AI_COMPLETE.</a:t>
-            </a:r>
-            <a:endParaRPr lang="en-US" sz="1200" dirty="0"/>
-          </a:p>
-        </p:txBody>
-      </p:sp>
-      <p:sp>
-        <p:nvSpPr>
-          <p:cNvPr id="27" name="Shape 25"/>
-          <p:cNvSpPr/>
-          <p:nvPr/>
-        </p:nvSpPr>
-        <p:spPr>
-          <a:xfrm>
-            <a:off x="457200" y="4069080"/>
-            <a:ext cx="457200" cy="457200"/>
-          </a:xfrm>
-          <a:prstGeom prst="ellipse">
-            <a:avLst/>
-          </a:prstGeom>
-          <a:solidFill>
-            <a:schemeClr val="accent4"/>
-          </a:solidFill>
-          <a:ln/>
+          <a:effectLst>
+            <a:outerShdw sx="100000" sy="100000" kx="0" ky="0" algn="bl" rotWithShape="0" blurRad="101600" dist="25400" dir="5400000">
+              <a:srgbClr val="0E1A2B">
+                <a:alpha val="18000"/>
+              </a:srgbClr>
+            </a:outerShdw>
+          </a:effectLst>
         </p:spPr>
       </p:sp>
       <p:pic>
         <p:nvPicPr>
-          <p:cNvPr id="28" name="Image 0" descr="preencoded.png">    </p:cNvPr>
+          <p:cNvPr id="5" name="Image 0" descr="shots/coco_detect.png">    </p:cNvPr>
           <p:cNvPicPr>
             <a:picLocks noChangeAspect="1"/>
           </p:cNvPicPr>
@@ -8182,8 +7527,8 @@
         </p:blipFill>
         <p:spPr>
           <a:xfrm>
-            <a:off x="566928" y="4178808"/>
-            <a:ext cx="237744" cy="237744"/>
+            <a:off x="2971800" y="1234440"/>
+            <a:ext cx="5715000" cy="3218688"/>
           </a:xfrm>
           <a:prstGeom prst="rect">
             <a:avLst/>
@@ -8192,37 +7537,370 @@
       </p:pic>
       <p:sp>
         <p:nvSpPr>
-          <p:cNvPr id="29" name="Text 26"/>
-          <p:cNvSpPr txBox="1"/>
-          <p:nvPr/>
-        </p:nvSpPr>
-        <p:spPr>
-          <a:xfrm>
-            <a:off x="1097280" y="4005072"/>
-            <a:ext cx="7589520" cy="594360"/>
-          </a:xfrm>
-          <a:prstGeom prst="rect">
-            <a:avLst/>
-          </a:prstGeom>
-          <a:noFill/>
-          <a:ln/>
-        </p:spPr>
-        <p:txBody>
-          <a:bodyPr wrap="square" lIns="0" tIns="0" rIns="0" bIns="0" rtlCol="0" anchor="ctr"/>
-          <a:lstStyle/>
-          <a:p>
-            <a:pPr indent="0" marL="0">
-              <a:buNone/>
-            </a:pPr>
-            <a:r>
-              <a:rPr lang="en-US" sz="1400" dirty="0">
+          <p:cNvPr id="6" name="Text 3"/>
+          <p:cNvSpPr txBox="1"/>
+          <p:nvPr/>
+        </p:nvSpPr>
+        <p:spPr>
+          <a:xfrm>
+            <a:off x="457200" y="1234440"/>
+            <a:ext cx="2286000" cy="228600"/>
+          </a:xfrm>
+          <a:prstGeom prst="rect">
+            <a:avLst/>
+          </a:prstGeom>
+          <a:noFill/>
+          <a:ln/>
+        </p:spPr>
+        <p:txBody>
+          <a:bodyPr wrap="square" lIns="0" tIns="0" rIns="0" bIns="0" rtlCol="0" anchor="t"/>
+          <a:lstStyle/>
+          <a:p>
+            <a:pPr indent="0" marL="0">
+              <a:buNone/>
+            </a:pPr>
+            <a:r>
+              <a:rPr lang="en-US" sz="1100" b="1" spc="100" kern="0" dirty="0">
+                <a:solidFill>
+                  <a:schemeClr val="accent5"/>
+                </a:solidFill>
+              </a:rPr>
+              <a:t>INPUT</a:t>
+            </a:r>
+            <a:endParaRPr lang="en-US" sz="1100" dirty="0"/>
+          </a:p>
+        </p:txBody>
+      </p:sp>
+      <p:sp>
+        <p:nvSpPr>
+          <p:cNvPr id="7" name="Text 4"/>
+          <p:cNvSpPr txBox="1"/>
+          <p:nvPr/>
+        </p:nvSpPr>
+        <p:spPr>
+          <a:xfrm>
+            <a:off x="457200" y="1481328"/>
+            <a:ext cx="2377440" cy="274320"/>
+          </a:xfrm>
+          <a:prstGeom prst="rect">
+            <a:avLst/>
+          </a:prstGeom>
+          <a:noFill/>
+          <a:ln/>
+        </p:spPr>
+        <p:txBody>
+          <a:bodyPr wrap="square" lIns="0" tIns="0" rIns="0" bIns="0" rtlCol="0" anchor="t"/>
+          <a:lstStyle/>
+          <a:p>
+            <a:pPr indent="0" marL="0">
+              <a:buNone/>
+            </a:pPr>
+            <a:r>
+              <a:rPr lang="en-US" sz="1200" b="1" dirty="0">
                 <a:solidFill>
                   <a:schemeClr val="tx1"/>
                 </a:solidFill>
-              </a:rPr>
-              <a:t>Each skill is a markdown file in .cortex/skills: reusable by any analyst, versioned in Git, and chained by CoCo CLI into one end-to-end workflow.</a:t>
-            </a:r>
-            <a:endParaRPr lang="en-US" sz="1400" dirty="0"/>
+                <a:latin typeface="Courier New" pitchFamily="34" charset="0"/>
+                <a:ea typeface="Courier New" pitchFamily="34" charset="-122"/>
+                <a:cs typeface="Courier New" pitchFamily="34" charset="-120"/>
+              </a:rPr>
+              <a:t>$muletrace-ingest</a:t>
+            </a:r>
+            <a:endParaRPr lang="en-US" sz="1200" dirty="0"/>
+          </a:p>
+        </p:txBody>
+      </p:sp>
+      <p:sp>
+        <p:nvSpPr>
+          <p:cNvPr id="8" name="Text 5"/>
+          <p:cNvSpPr txBox="1"/>
+          <p:nvPr/>
+        </p:nvSpPr>
+        <p:spPr>
+          <a:xfrm>
+            <a:off x="457200" y="1764792"/>
+            <a:ext cx="2377440" cy="502920"/>
+          </a:xfrm>
+          <a:prstGeom prst="rect">
+            <a:avLst/>
+          </a:prstGeom>
+          <a:noFill/>
+          <a:ln/>
+        </p:spPr>
+        <p:txBody>
+          <a:bodyPr wrap="square" lIns="0" tIns="0" rIns="0" bIns="0" rtlCol="0" anchor="t"/>
+          <a:lstStyle/>
+          <a:p>
+            <a:pPr indent="0" marL="0">
+              <a:buNone/>
+            </a:pPr>
+            <a:r>
+              <a:rPr lang="en-US" sz="1100" dirty="0">
+                <a:solidFill>
+                  <a:schemeClr val="accent6"/>
+                </a:solidFill>
+              </a:rPr>
+              <a:t>Loads 10,259 transactions, 603 accounts and 17 policy sections into Snowflake and verifies the counts.</a:t>
+            </a:r>
+            <a:endParaRPr lang="en-US" sz="1100" dirty="0"/>
+          </a:p>
+        </p:txBody>
+      </p:sp>
+      <p:sp>
+        <p:nvSpPr>
+          <p:cNvPr id="9" name="Text 6"/>
+          <p:cNvSpPr txBox="1"/>
+          <p:nvPr/>
+        </p:nvSpPr>
+        <p:spPr>
+          <a:xfrm>
+            <a:off x="457200" y="2331720"/>
+            <a:ext cx="2286000" cy="228600"/>
+          </a:xfrm>
+          <a:prstGeom prst="rect">
+            <a:avLst/>
+          </a:prstGeom>
+          <a:noFill/>
+          <a:ln/>
+        </p:spPr>
+        <p:txBody>
+          <a:bodyPr wrap="square" lIns="0" tIns="0" rIns="0" bIns="0" rtlCol="0" anchor="t"/>
+          <a:lstStyle/>
+          <a:p>
+            <a:pPr indent="0" marL="0">
+              <a:buNone/>
+            </a:pPr>
+            <a:r>
+              <a:rPr lang="en-US" sz="1100" b="1" spc="100" kern="0" dirty="0">
+                <a:solidFill>
+                  <a:schemeClr val="accent3"/>
+                </a:solidFill>
+              </a:rPr>
+              <a:t>PROCESSING</a:t>
+            </a:r>
+            <a:endParaRPr lang="en-US" sz="1100" dirty="0"/>
+          </a:p>
+        </p:txBody>
+      </p:sp>
+      <p:sp>
+        <p:nvSpPr>
+          <p:cNvPr id="10" name="Text 7"/>
+          <p:cNvSpPr txBox="1"/>
+          <p:nvPr/>
+        </p:nvSpPr>
+        <p:spPr>
+          <a:xfrm>
+            <a:off x="457200" y="2578608"/>
+            <a:ext cx="2377440" cy="274320"/>
+          </a:xfrm>
+          <a:prstGeom prst="rect">
+            <a:avLst/>
+          </a:prstGeom>
+          <a:noFill/>
+          <a:ln/>
+        </p:spPr>
+        <p:txBody>
+          <a:bodyPr wrap="square" lIns="0" tIns="0" rIns="0" bIns="0" rtlCol="0" anchor="t"/>
+          <a:lstStyle/>
+          <a:p>
+            <a:pPr indent="0" marL="0">
+              <a:buNone/>
+            </a:pPr>
+            <a:r>
+              <a:rPr lang="en-US" sz="1200" b="1" dirty="0">
+                <a:solidFill>
+                  <a:schemeClr val="tx1"/>
+                </a:solidFill>
+                <a:latin typeface="Courier New" pitchFamily="34" charset="0"/>
+                <a:ea typeface="Courier New" pitchFamily="34" charset="-122"/>
+                <a:cs typeface="Courier New" pitchFamily="34" charset="-120"/>
+              </a:rPr>
+              <a:t>$muletrace-detect</a:t>
+            </a:r>
+            <a:endParaRPr lang="en-US" sz="1200" dirty="0"/>
+          </a:p>
+        </p:txBody>
+      </p:sp>
+      <p:sp>
+        <p:nvSpPr>
+          <p:cNvPr id="11" name="Text 8"/>
+          <p:cNvSpPr txBox="1"/>
+          <p:nvPr/>
+        </p:nvSpPr>
+        <p:spPr>
+          <a:xfrm>
+            <a:off x="457200" y="2862072"/>
+            <a:ext cx="2377440" cy="502920"/>
+          </a:xfrm>
+          <a:prstGeom prst="rect">
+            <a:avLst/>
+          </a:prstGeom>
+          <a:noFill/>
+          <a:ln/>
+        </p:spPr>
+        <p:txBody>
+          <a:bodyPr wrap="square" lIns="0" tIns="0" rIns="0" bIns="0" rtlCol="0" anchor="t"/>
+          <a:lstStyle/>
+          <a:p>
+            <a:pPr indent="0" marL="0">
+              <a:buNone/>
+            </a:pPr>
+            <a:r>
+              <a:rPr lang="en-US" sz="1100" dirty="0">
+                <a:solidFill>
+                  <a:schemeClr val="accent6"/>
+                </a:solidFill>
+              </a:rPr>
+              <a:t>Refreshes Dynamic Tables, runs the Snowpark graph detector and ranks 6 laundering networks.</a:t>
+            </a:r>
+            <a:endParaRPr lang="en-US" sz="1100" dirty="0"/>
+          </a:p>
+        </p:txBody>
+      </p:sp>
+      <p:sp>
+        <p:nvSpPr>
+          <p:cNvPr id="12" name="Text 9"/>
+          <p:cNvSpPr txBox="1"/>
+          <p:nvPr/>
+        </p:nvSpPr>
+        <p:spPr>
+          <a:xfrm>
+            <a:off x="457200" y="3429000"/>
+            <a:ext cx="2286000" cy="228600"/>
+          </a:xfrm>
+          <a:prstGeom prst="rect">
+            <a:avLst/>
+          </a:prstGeom>
+          <a:noFill/>
+          <a:ln/>
+        </p:spPr>
+        <p:txBody>
+          <a:bodyPr wrap="square" lIns="0" tIns="0" rIns="0" bIns="0" rtlCol="0" anchor="t"/>
+          <a:lstStyle/>
+          <a:p>
+            <a:pPr indent="0" marL="0">
+              <a:buNone/>
+            </a:pPr>
+            <a:r>
+              <a:rPr lang="en-US" sz="1100" b="1" spc="100" kern="0" dirty="0">
+                <a:solidFill>
+                  <a:schemeClr val="accent2"/>
+                </a:solidFill>
+              </a:rPr>
+              <a:t>OUTPUT</a:t>
+            </a:r>
+            <a:endParaRPr lang="en-US" sz="1100" dirty="0"/>
+          </a:p>
+        </p:txBody>
+      </p:sp>
+      <p:sp>
+        <p:nvSpPr>
+          <p:cNvPr id="13" name="Text 10"/>
+          <p:cNvSpPr txBox="1"/>
+          <p:nvPr/>
+        </p:nvSpPr>
+        <p:spPr>
+          <a:xfrm>
+            <a:off x="457200" y="3675888"/>
+            <a:ext cx="2377440" cy="274320"/>
+          </a:xfrm>
+          <a:prstGeom prst="rect">
+            <a:avLst/>
+          </a:prstGeom>
+          <a:noFill/>
+          <a:ln/>
+        </p:spPr>
+        <p:txBody>
+          <a:bodyPr wrap="square" lIns="0" tIns="0" rIns="0" bIns="0" rtlCol="0" anchor="t"/>
+          <a:lstStyle/>
+          <a:p>
+            <a:pPr indent="0" marL="0">
+              <a:buNone/>
+            </a:pPr>
+            <a:r>
+              <a:rPr lang="en-US" sz="1200" b="1" dirty="0">
+                <a:solidFill>
+                  <a:schemeClr val="tx1"/>
+                </a:solidFill>
+                <a:latin typeface="Courier New" pitchFamily="34" charset="0"/>
+                <a:ea typeface="Courier New" pitchFamily="34" charset="-122"/>
+                <a:cs typeface="Courier New" pitchFamily="34" charset="-120"/>
+              </a:rPr>
+              <a:t>$muletrace-investigate</a:t>
+            </a:r>
+            <a:endParaRPr lang="en-US" sz="1200" dirty="0"/>
+          </a:p>
+        </p:txBody>
+      </p:sp>
+      <p:sp>
+        <p:nvSpPr>
+          <p:cNvPr id="14" name="Text 11"/>
+          <p:cNvSpPr txBox="1"/>
+          <p:nvPr/>
+        </p:nvSpPr>
+        <p:spPr>
+          <a:xfrm>
+            <a:off x="457200" y="3959352"/>
+            <a:ext cx="2377440" cy="502920"/>
+          </a:xfrm>
+          <a:prstGeom prst="rect">
+            <a:avLst/>
+          </a:prstGeom>
+          <a:noFill/>
+          <a:ln/>
+        </p:spPr>
+        <p:txBody>
+          <a:bodyPr wrap="square" lIns="0" tIns="0" rIns="0" bIns="0" rtlCol="0" anchor="t"/>
+          <a:lstStyle/>
+          <a:p>
+            <a:pPr indent="0" marL="0">
+              <a:buNone/>
+            </a:pPr>
+            <a:r>
+              <a:rPr lang="en-US" sz="1100" dirty="0">
+                <a:solidFill>
+                  <a:schemeClr val="accent6"/>
+                </a:solidFill>
+              </a:rPr>
+              <a:t>Pulls the evidence pack, quotes AML-04 §3.</a:t>
+            </a:r>
+            <a:endParaRPr lang="en-US" sz="1100" dirty="0"/>
+          </a:p>
+        </p:txBody>
+      </p:sp>
+      <p:sp>
+        <p:nvSpPr>
+          <p:cNvPr id="15" name="Text 12"/>
+          <p:cNvSpPr txBox="1"/>
+          <p:nvPr/>
+        </p:nvSpPr>
+        <p:spPr>
+          <a:xfrm>
+            <a:off x="2971800" y="4526280"/>
+            <a:ext cx="5715000" cy="228600"/>
+          </a:xfrm>
+          <a:prstGeom prst="rect">
+            <a:avLst/>
+          </a:prstGeom>
+          <a:noFill/>
+          <a:ln/>
+        </p:spPr>
+        <p:txBody>
+          <a:bodyPr wrap="square" lIns="0" tIns="0" rIns="0" bIns="0" rtlCol="0" anchor="t"/>
+          <a:lstStyle/>
+          <a:p>
+            <a:pPr indent="0" marL="0">
+              <a:buNone/>
+            </a:pPr>
+            <a:r>
+              <a:rPr lang="en-US" sz="1000" i="1" dirty="0">
+                <a:solidFill>
+                  <a:schemeClr val="accent6"/>
+                </a:solidFill>
+              </a:rPr>
+              <a:t>Real CoCo CLI session running the MuleTrace skills against Snowflake (connection: muletrace).</a:t>
+            </a:r>
+            <a:endParaRPr lang="en-US" sz="1000" dirty="0"/>
           </a:p>
         </p:txBody>
       </p:sp>
@@ -14026,7 +13704,7 @@
                   <a:schemeClr val="accent6"/>
                 </a:solidFill>
               </a:rPr>
-              <a:t>Graph detection of four laundering typologies, evidence and policy clauses on every alert, plain-English Q&amp;A, one-click STR, designed Snowflake-native.</a:t>
+              <a:t>Graph detection of four laundering typologies, evidence and policy clauses on every alert, plain-English Q&amp;A, one-click STR. Running on Snowflake, built with CoCo CLI.</a:t>
             </a:r>
             <a:endParaRPr lang="en-US" sz="1300" dirty="0"/>
           </a:p>
@@ -14674,7 +14352,7 @@
                   <a:schemeClr val="tx1"/>
                 </a:solidFill>
               </a:rPr>
-              <a:t>Live investigator app</a:t>
+              <a:t>Live investigator app + measured accuracy</a:t>
             </a:r>
             <a:endParaRPr lang="en-US" sz="1300" dirty="0"/>
           </a:p>
@@ -14730,7 +14408,7 @@
                   <a:schemeClr val="tx1"/>
                 </a:solidFill>
               </a:rPr>
-              <a:t>Graph detector with measured accuracy</a:t>
+              <a:t>Running on Snowflake: Snowpark, Cortex Search, Cortex Agent</a:t>
             </a:r>
             <a:endParaRPr lang="en-US" sz="1300" dirty="0"/>
           </a:p>
@@ -14786,7 +14464,7 @@
                   <a:schemeClr val="tx1"/>
                 </a:solidFill>
               </a:rPr>
-              <a:t>Copilot, STR drafts, audit log</a:t>
+              <a:t>3 CoCo CLI skills, end to end</a:t>
             </a:r>
             <a:endParaRPr lang="en-US" sz="1300" dirty="0"/>
           </a:p>
@@ -14842,7 +14520,7 @@
                   <a:schemeClr val="tx1"/>
                 </a:solidFill>
               </a:rPr>
-              <a:t>Snowflake SQL + 3 CoCo skills</a:t>
+              <a:t>STR drafts via AI_COMPLETE</a:t>
             </a:r>
             <a:endParaRPr lang="en-US" sz="1300" dirty="0"/>
           </a:p>
@@ -15038,7 +14716,7 @@
                   <a:schemeClr val="tx1"/>
                 </a:solidFill>
               </a:rPr>
-              <a:t>Full workflow running in Snowflake</a:t>
+              <a:t>Cortex Agent behind the live app</a:t>
             </a:r>
             <a:endParaRPr lang="en-US" sz="1300" dirty="0"/>
           </a:p>
@@ -15094,7 +14772,7 @@
                   <a:schemeClr val="tx1"/>
                 </a:solidFill>
               </a:rPr>
-              <a:t>Cortex Agent answering in the live app</a:t>
+              <a:t>Alerts to the compliance inbox</a:t>
             </a:r>
             <a:endParaRPr lang="en-US" sz="1300" dirty="0"/>
           </a:p>
@@ -15150,7 +14828,7 @@
                   <a:schemeClr val="tx1"/>
                 </a:solidFill>
               </a:rPr>
-              <a:t>Hourly detection task + alerts</a:t>
+              <a:t>PDF policies via AI_PARSE_DOCUMENT</a:t>
             </a:r>
             <a:endParaRPr lang="en-US" sz="1300" dirty="0"/>
           </a:p>
@@ -15206,7 +14884,7 @@
                   <a:schemeClr val="tx1"/>
                 </a:solidFill>
               </a:rPr>
-              <a:t>PDF policies via AI_PARSE_DOCUMENT</a:t>
+              <a:t>Enterprise masking + access history</a:t>
             </a:r>
             <a:endParaRPr lang="en-US" sz="1300" dirty="0"/>
           </a:p>
@@ -16228,7 +15906,7 @@
                   <a:schemeClr val="tx1"/>
                 </a:solidFill>
               </a:rPr>
-              <a:t>The same detector runs locally and as a Snowpark procedure</a:t>
+              <a:t>Same detector locally and as a Snowpark procedure, hourly task</a:t>
             </a:r>
             <a:endParaRPr lang="en-US" sz="1200" dirty="0"/>
           </a:p>
@@ -16284,7 +15962,7 @@
                   <a:schemeClr val="tx1"/>
                 </a:solidFill>
               </a:rPr>
-              <a:t>Cortex Agent, Cortex Search, semantic view, Dynamic Tables, AI_COMPLETE</a:t>
+              <a:t>Live on Snowflake: Cortex Agent, Cortex Search, semantic view, AI_COMPLETE</a:t>
             </a:r>
             <a:endParaRPr lang="en-US" sz="1200" dirty="0"/>
           </a:p>

</xml_diff>